<commit_message>
Finalize integrated online lab scripts and synchronized teaching artifacts
</commit_message>
<xml_diff>
--- a/산출물/교재/PPTX/통합반_온라인/통합반_08일차.pptx
+++ b/산출물/교재/PPTX/통합반_온라인/통합반_08일차.pptx
@@ -702,7 +702,7 @@
           <a:lstStyle/>
           <a:p>
             <a:r>
-              <a:t>명세를 다룬 SDD와 방금 본 BDD를 나란히 놓겠습니다. 왼쪽 SDD는 무엇을 만들고 무엇을 지킬지 명세를 중심으로 정하고, 구현과 검증에도 그 기준을 이어 가는 접근입니다. 오른쪽 BDD는 구체적인 행동 사례를 함께 논의해서 기대를 맞추고, 그 사례를 실행 가능한 검증에 연결하는 접근이에요. 두 방식을 구현 전과 구현 후로 나누면 정확하지 않습니다. 거절하면 명령이 없어야 한다는 시나리오는 구현하기 전에도 쓸 수 있죠. 오히려 그때 사유가 없으면 거절을 받을 것인지 물어 보면, 명세에서 빠뜨린 조건을 찾을 수 있습니다. 구현한 뒤에는 같은 시나리오로 실제 행동을 확인하고요. 이 수업에서는 앞 회차에 명세를 정리했고, 이번 회차에 시나리오와 검증을 다룹니다. 이것은 학습 순서입니다. 실제 작업에서는 명세와 사례를 오가며 기대를 구체화할 수 있어요. 앞 실습에서 저장한 입력과 조회 자료, 기대 결과가 그 출발점입니다. 지키겠다는 문장이 있으면 확인할 사례를 고를 수 있고, 사례가 구체적이면 문장의 모호함을 발견할 수 있습니다. 이렇게 서로 보완하면서 변경의 기준을 남기는 겁니다. [출처·낭독 제외] https://cucumber.io/docs/bdd/</a:t>
+              <a:t>명세를 다룬 SDD와 방금 본 BDD를 나란히 놓겠습니다. 왼쪽 SDD는 무엇을 만들고 무엇을 지킬지 명세를 중심으로 정하고, 구현과 검증에도 그 기준을 이어 가는 접근입니다. 오른쪽 BDD는 구체적인 행동 사례를 함께 논의해서 기대를 맞추고, 그 사례를 실행 가능한 검증에 연결하는 접근이에요. 두 방식을 구현 전과 구현 후로 나누면 정확하지 않습니다. 거절하면 명령이 없어야 한다는 시나리오는 구현하기 전에도 쓸 수 있죠. 오히려 그때 사유가 없으면 거절을 받을 것인지 물어 보면, 명세에서 빠뜨린 조건을 찾을 수 있습니다. 구현한 뒤에는 같은 시나리오로 실제 행동을 확인하고요. 이 수업에서는 앞 회차에 명세를 정리했고, 이번 회차에 시나리오와 검증을 다룹니다. 이것은 학습 순서입니다. 실제 작업에서는 명세와 사례를 오가며 기대를 구체화할 수 있어요. 앞 실습에서 저장한 입력과 조회 자료, 기대 결과가 그 출발점입니다. 지키겠다는 문장이 있으면 확인할 사례를 고를 수 있고, 사례가 구체적이면 문장의 모호함을 발견할 수 있습니다. 이렇게 서로 보완하면서 변경의 기준을 남기는 겁니다.</a:t>
             </a:r>
           </a:p>
         </p:txBody>
@@ -2172,7 +2172,7 @@
           <a:lstStyle/>
           <a:p>
             <a:r>
-              <a:t>실패를 찾았다면 이제 원인을 좁혀야 합니다. 표의 가운데 칸은 정답처럼 고칠 곳을 지정하는 칸이 아니라, 먼저 대조할 자료입니다. 단계를 건너뛰었다면 지침과 호출 기록을 함께 봅니다. 지침이 모호했는지, 필요한 도구를 쓰지 않았는지, 호출했지만 실패했는지에 따라 조치가 달라져요. 기준값이 다르면 규칙과 그 버전, 실제 입력과 단위를 확인합니다. 결과 항목이 빠졌다면 먼저 명세에 그 항목이 요구돼 있는지 봅니다. 이미 요구돼 있다면 출력 구현이나 검사가 놓친 것일 수 있어요. 누락됐다는 이유만으로 명세에서 그 항목을 지우는 것은 해결이 아닙니다. 반대로 시험의 기대값을 옮겨 적다가 잘못 적었을 수도 있습니다. 그때는 원래 요구와 근거를 대조해서 시험을 바로잡고 이유를 남깁니다. 요구가 바뀌었다면 명세와 시나리오를 함께 갱신해야 하고요. 마지막 줄이 가리키는 것은 근거 없이 기대값을 낮추는 일입니다. 현재 나온 결과를 통과시키려고 기준을 바꾸면 같은 오류가 다음에도 통과합니다. 실패 기록에서 입력, 기대, 실제 결과를 확인한 다음 원인을 고치고, 해당 시험과 기존 시험을 다시 실행하세요.</a:t>
+              <a:t>실패를 찾았다면 이제 원인을 좁혀야 합니다. 표의 가운데 칸은 정답처럼 고칠 곳을 지정하는 칸이 아니라, 먼저 대조할 자료입니다. 단계를 건너뛰었다면 지침과 호출 기록을 함께 봅니다. 지침이 모호했는지, 필요한 도구를 쓰지 않았는지, 호출했지만 실패했는지에 따라 조치가 달라져요. 기준값이 다르면 규칙과 그 버전, 실제 입력과 단위를 확인합니다. 결과 항목이 빠졌다면 먼저 명세에 그 항목이 요구돼 있는지 봅니다. 이미 요구돼 있다면 출력 구현이나 검사가 놓친 것일 수 있어요. 누락됐다는 이유만으로 명세에서 그 항목을 지우는 것은 해결이 아닙니다. 반대로 시험의 기대값을 옮겨 적다가 잘못 적었을 수도 있습니다. 그때는 원래 요구와 근거를 대조해서 시험을 바로잡고 이유를 남깁니다. 요구가 바뀌었다면 명세와 시나리오를 함께 갱신해야 하고요. 마지막 줄이 가리키는 것은 근거 없이 기대값을 낮추는 일입니다. 현재 나온 결과를 통과시키려고 기준을 바꾸면 같은 오류가 다음에도 통과합니다. 실패 기록에서 입력, 기대, 실제 결과를 확인한 다음 원인을 고치고, 해당 시험과 기존 시험을 다시 실행하겠습니다.</a:t>
             </a:r>
           </a:p>
         </p:txBody>
@@ -2242,7 +2242,7 @@
           <a:lstStyle/>
           <a:p>
             <a:r>
-              <a:t>지금까지 세 단원에 걸쳐, 명세의 약속을 Given, When, Then으로 적고, 그 시나리오를 시험으로 바꾸고, 실행마다 달라지는 출력에서 무엇을 실패로 셀지까지 가려 봤죠. 이제 그걸 직접 해 볼 차례입니다. 실습은 넷이 이어지는데요, 첫 실습의 할 일은 명세 spec.md를 썼던 그 에이전트를 그대로 가져와서, 다섯 경우의 행동 기준을 시나리오 문서로 적는 거예요. 화면 둘째 카드가 그 다섯 경우예요. 일반 정비, 긴급 정비, 필수 정보 누락, 승인 거절, 도구 오류. 경우마다 Given, When, Then을 나눠 적고, 입력값하고 기대 상태, 지켜야 할 출력 계약도 같이 적습니다. 다 적었으면 마지막 카드의 성공 기준으로 두 가지를 점검해 주세요. Then이 건수나 값처럼 실행 결과로 가릴 수 있는 사실인지, 그리고 금지 조건이 일어나지 않아야 할 일로 들어 있는지요. 이 실습이 끝나면 그 다섯 경우의 시나리오 문서가 남습니다. 이어서 안내할 두 번째 실습에서는 이 문서를 실제 실행과 연결합니다. 입력값뿐 아니라 비교할 조회 자료와 기대 결과도 함께 남겨 주세요.</a:t>
+              <a:t>지금까지 세 단원에 걸쳐, 명세의 약속을 Given, When, Then으로 적고, 그 시나리오를 시험으로 바꾸고, 실행마다 달라지는 출력에서 무엇을 실패로 셀지까지 가려 봤죠. 이제 그걸 직접 해 볼 차례입니다. 실습은 넷이 이어지는데요, 첫 실습의 할 일은 명세 spec.md를 썼던 그 에이전트를 그대로 가져와서, 다섯 경우의 행동 기준을 시나리오 문서로 적는 거예요. 화면 둘째 카드가 그 다섯 경우예요. 일반 정비, 긴급 정비, 필수 정보 누락, 승인 거절, 도구 오류. 경우마다 Given, When, Then을 나눠 적고, 입력값하고 기대 상태, 지켜야 할 출력 계약도 같이 적습니다. 다 적었으면 마지막 카드의 성공 기준으로 두 가지를 점검하겠습니다. Then이 건수나 값처럼 실행 결과로 가릴 수 있는 사실인지, 그리고 금지 조건이 일어나지 않아야 할 일로 들어 있는지요. 이 실습이 끝나면 그 다섯 경우의 시나리오 문서가 남습니다. 이어서 안내할 두 번째 실습에서는 이 문서를 실제 실행과 연결합니다. 입력값뿐 아니라 비교할 조회 자료와 기대 결과도 함께 남기겠습니다.</a:t>
             </a:r>
           </a:p>
         </p:txBody>
@@ -2312,7 +2312,7 @@
           <a:lstStyle/>
           <a:p>
             <a:r>
-              <a:t>두 번째 실습에서는 첫 실습에서 작성할 다섯 경우의 시나리오로, 에이전트의 동작을 반복 검증하는 실습을 준비합니다. 적어 둔 시나리오는 아직 글이라, 에이전트가 정말 그렇게 움직이는지는 돌려 봐야 알죠. 화면 첫 번째 카드의 입력이 그 다섯 경우의 시나리오 문서예요. 이걸 준비된 자동 시험이나 반복 실행 스크립트에 잇고, 같은 입력으로 여러 번 실행합니다. 실행 결과는 로그와 결과 파일로 남아요. 실제 출력과 기대값을 견줘서, 어느 조건에서 규칙을 어겼는지 찾아 위반 목록에 적어 주세요. 이 실습의 성공 기준은 어긋남마다 판정이 붙어 있는 겁니다. 설명 문장이 달라진 표현 차이인지, 항목이 빠지거나 금지된 일이 일어난 계약 위반인지를 가르면 돼요. 실습이 끝나면 실행 결과 로그와, 판정이 붙은 위반 목록이 남습니다. 조회 자료와 설정도 함께 기록해 차이가 생긴 조건을 구별하세요. 허용할 과정의 차이인지, 실제 조건을 어긴 것인지 근거를 붙이는 것이 핵심입니다.</a:t>
+              <a:t>두 번째 실습에서는 첫 실습에서 작성할 다섯 경우의 시나리오로, 에이전트의 동작을 반복 검증하는 실습을 준비합니다. 적어 둔 시나리오는 아직 글이라, 에이전트가 정말 그렇게 움직이는지는 돌려 봐야 알죠. 화면 첫 번째 카드의 입력이 그 다섯 경우의 시나리오 문서예요. 이걸 준비된 자동 시험이나 반복 실행 스크립트에 잇고, 같은 입력으로 여러 번 실행합니다. 실행 결과는 로그와 결과 파일로 남아요. 실제 출력과 기대값을 견줘서, 어느 조건에서 규칙을 어겼는지 찾아 위반 목록에 적겠습니다. 이 실습의 성공 기준은 어긋남마다 판정이 붙어 있는 겁니다. 설명 문장이 달라진 표현 차이인지, 항목이 빠지거나 금지된 일이 일어난 계약 위반인지를 가르면 돼요. 실습이 끝나면 실행 결과 로그와, 판정이 붙은 위반 목록이 남습니다. 조회 자료와 설정도 함께 기록해 차이가 생긴 조건을 구별하겠습니다. 허용할 과정의 차이인지, 실제 조건을 어긴 것인지 근거를 붙이는 것이 핵심입니다.</a:t>
             </a:r>
           </a:p>
         </p:txBody>
@@ -2382,7 +2382,7 @@
           <a:lstStyle/>
           <a:p>
             <a:r>
-              <a:t>세 번째 실습에서는 반복 검증에서 남길 위반 목록을 출발점으로, 오류를 고치고 기존 기능이 그대로인지 확인하는 실습을 준비합니다. 위반 목록에서 실제로 실패한 시나리오만 골라 원인을 따라갑니다. 실패의 증상을 보고, 고칠 곳이 프롬프트 같은 지침인지, 지식 그래프의 기준값인지, 명세인지, 코드인지부터 가려 주세요. 이론에서 본 고칠 곳의 표 그대로예요. 가린 곳을 고친 다음 그 시나리오를 다시 돌리고요. 이때 기대값을 낮춰서 통과시키지는 않습니다. 마지막에는 전체 회귀를 돌립니다. 긴급 조건이 동작하면서, 기존의 일반 요청, 필수 정보가 빠진 요청을 확정하지 않는 보류, 그리고 거절 조건이 그대로 통과하면 성공이에요. 무엇을 왜 고쳤는지 적은 수정 기록과 전체 회귀 결과가 남습니다. 실패가 없다면 억지로 오류를 만들거나 고칠 필요는 없습니다. 확인한 범위와 남은 경우를 기록하세요. 실패가 있다면 수정한 시험뿐 아니라 준비한 전체 시나리오를 다시 확인합니다.</a:t>
+              <a:t>세 번째 실습에서는 반복 검증에서 남길 위반 목록을 출발점으로, 오류를 고치고 기존 기능이 그대로인지 확인하는 실습을 준비합니다. 위반 목록에서 실제로 실패한 시나리오만 골라 원인을 따라갑니다. 실패의 증상을 보고, 고칠 곳이 프롬프트 같은 지침인지, 지식 그래프의 기준값인지, 명세인지, 코드인지부터 가려 보겠습니다. 이론에서 본 고칠 곳의 표 그대로예요. 가린 곳을 고친 다음 그 시나리오를 다시 돌리고요. 이때 기대값을 낮춰서 통과시키지는 않습니다. 마지막에는 전체 회귀를 돌립니다. 긴급 조건이 동작하면서, 기존의 일반 요청, 필수 정보가 빠진 요청을 확정하지 않는 보류, 그리고 거절 조건이 그대로 통과하면 성공이에요. 무엇을 왜 고쳤는지 적은 수정 기록과 전체 회귀 결과가 남습니다. 실패가 없다면 억지로 오류를 만들거나 고칠 필요는 없습니다. 확인한 범위와 남은 경우를 기록하겠습니다. 실패가 있다면 수정한 시험뿐 아니라 준비한 전체 시나리오를 다시 확인합니다.</a:t>
             </a:r>
           </a:p>
         </p:txBody>
@@ -2452,7 +2452,7 @@
           <a:lstStyle/>
           <a:p>
             <a:r>
-              <a:t>네 번째 실습은 여러 출처를 연결해 교대 인수인계서를 만드는 활동입니다. 앞의 세 실습이 기대를 적고 실행해서 고치는 과정이라면, 여기서는 결과의 바탕이 되는 업무 자료를 어떻게 함께 읽을지 확인합니다. 다음 담당자가 알아야 할 완료 작업과 남은 요청, 주의 사항을 세 출처에서 정리할 거예요. 입력은 설비 이벤트, 정비 이력, 부품 자료의 조회 결과입니다. 실습 환경에 따라 실제 조회 결과 또는 같은 스키마로 준비한 자료를 사용합니다. 단순히 세 문서를 이어 붙이는 것이 아니라, 같은 설비나 요청을 가리키는지와 각 기록의 시점을 맞춰 봐야 합니다. 두 번째 카드의 데이터 패브릭은 여러 곳의 데이터를 연결하고 관리해 활용하는 더 넓은 접근입니다. 데이터를 옮기지 않는 방식만을 뜻하지는 않아요. 이번 실습에서는 그중 원천의 자료를 연결해 읽고 출처를 추적하는 관점을 다룹니다. 새 데이터 플랫폼을 구축하는 활동은 아닙니다. 인수인계 항목마다 어느 자료를 근거로 썼는지와 그 자료의 시각을 붙이세요. 방금 조회한 과거 기록일 수도 있으므로, 조회 시각과 사건이 일어난 시각을 구별해야 합니다. 한 출처를 읽지 못했다면 관련 작업이 없다고 단정하지 말고 확인하지 못한 범위를 적습니다. 출처끼리 상태가 다르면 어느 시점의 기록인지 확인하고, 해결되지 않은 차이도 남겨야 해요. 성공 기준은 다음 담당자가 각 항목의 근거와 미확인 부분을 찾아갈 수 있는 것입니다. 네 실습의 목표를 모두 살펴봤습니다. 다음 시간에는 시나리오 작성부터 반복 검증과 수정, 교대 인수인계 순서로 직접 진행하겠습니다.</a:t>
+              <a:t>네 번째 실습은 여러 출처를 연결해 교대 인수인계서를 만드는 활동입니다. 앞의 세 실습이 기대를 적고 실행해서 고치는 과정이라면, 여기서는 결과의 바탕이 되는 업무 자료를 어떻게 함께 읽을지 확인합니다. 다음 담당자가 알아야 할 완료 작업과 남은 요청, 주의 사항을 세 출처에서 정리할 거예요. 입력은 설비 이벤트, 정비 이력, 부품 자료의 조회 결과입니다. 실습 환경에 따라 실제 조회 결과 또는 같은 스키마로 준비한 자료를 사용합니다. 단순히 세 문서를 이어 붙이는 것이 아니라, 같은 설비나 요청을 가리키는지와 각 기록의 시점을 맞춰 봐야 합니다. 두 번째 카드의 데이터 패브릭은 여러 곳의 데이터를 연결하고 관리해 활용하는 더 넓은 접근입니다. 데이터를 옮기지 않는 방식만을 뜻하지는 않아요. 이번 실습에서는 그중 원천의 자료를 연결해 읽고 출처를 추적하는 관점을 다룹니다. 새 데이터 플랫폼을 구축하는 활동은 아닙니다. 인수인계 항목마다 어느 자료를 근거로 썼는지와 그 자료의 시각을 붙이겠습니다. 방금 조회한 과거 기록일 수도 있으므로, 조회 시각과 사건이 일어난 시각을 구별해야 합니다. 한 출처를 읽지 못했다면 관련 작업이 없다고 단정하지 말고 확인하지 못한 범위를 적습니다. 출처끼리 상태가 다르면 어느 시점의 기록인지 확인하고, 해결되지 않은 차이도 남겨야 해요. 성공 기준은 다음 담당자가 각 항목의 근거와 미확인 부분을 찾아갈 수 있는 것입니다. 네 실습의 목표를 모두 살펴봤습니다. 이제 시나리오 작성부터 반복 검증과 수정, 교대 인수인계 순서로 직접 진행하겠습니다.</a:t>
             </a:r>
           </a:p>
         </p:txBody>
@@ -2522,7 +2522,7 @@
           <a:lstStyle/>
           <a:p>
             <a:r>
-              <a:t>[출처·낭독 제외] https://www.ibm.com/think/topics/data-fabric</a:t>
+              <a:t>37~38장 통합 발화는 37장 발표자 노트를 따른다.</a:t>
             </a:r>
           </a:p>
         </p:txBody>
@@ -4297,6 +4297,76 @@
 </p:notes>
 </file>
 
+<file path=ppt/notesSlides/notesSlide59.xml><?xml version="1.0" encoding="utf-8"?>
+<p:notes xmlns:a="http://schemas.openxmlformats.org/drawingml/2006/main" xmlns:p="http://schemas.openxmlformats.org/presentationml/2006/main" xmlns:r="http://schemas.openxmlformats.org/officeDocument/2006/relationships">
+  <p:cSld>
+    <p:spTree>
+      <p:nvGrpSpPr>
+        <p:cNvPr id="1" name=""/>
+        <p:cNvGrpSpPr/>
+        <p:nvPr/>
+      </p:nvGrpSpPr>
+      <p:grpSpPr>
+        <a:xfrm>
+          <a:off x="0" y="0"/>
+          <a:ext cx="0" cy="0"/>
+          <a:chOff x="0" y="0"/>
+          <a:chExt cx="0" cy="0"/>
+        </a:xfrm>
+      </p:grpSpPr>
+      <p:sp>
+        <p:nvSpPr>
+          <p:cNvPr id="2" name="Slide Image Placeholder 1"/>
+          <p:cNvSpPr>
+            <a:spLocks noGrp="1"/>
+          </p:cNvSpPr>
+          <p:nvPr>
+            <p:ph type="sldImg" idx="2"/>
+          </p:nvPr>
+        </p:nvSpPr>
+        <p:spPr/>
+      </p:sp>
+      <p:sp>
+        <p:nvSpPr>
+          <p:cNvPr id="3" name="Notes Placeholder 2"/>
+          <p:cNvSpPr>
+            <a:spLocks noGrp="1"/>
+          </p:cNvSpPr>
+          <p:nvPr>
+            <p:ph type="body" idx="3" sz="quarter"/>
+          </p:nvPr>
+        </p:nvSpPr>
+        <p:spPr/>
+        <p:txBody>
+          <a:bodyPr/>
+          <a:lstStyle/>
+          <a:p>
+            <a:r>
+              <a:t>31~32장 통합 발화는 31장 발표자 노트를 따른다.</a:t>
+            </a:r>
+          </a:p>
+        </p:txBody>
+      </p:sp>
+      <p:sp>
+        <p:nvSpPr>
+          <p:cNvPr id="4" name="Slide Number Placeholder 3"/>
+          <p:cNvSpPr>
+            <a:spLocks noGrp="1"/>
+          </p:cNvSpPr>
+          <p:nvPr>
+            <p:ph type="sldNum" idx="5" sz="quarter"/>
+          </p:nvPr>
+        </p:nvSpPr>
+        <p:spPr/>
+      </p:sp>
+    </p:spTree>
+  </p:cSld>
+  <p:clrMapOvr>
+    <a:masterClrMapping/>
+  </p:clrMapOvr>
+</p:notes>
+</file>
+
 <file path=ppt/notesSlides/notesSlide6.xml><?xml version="1.0" encoding="utf-8"?>
 <p:notes xmlns:a="http://schemas.openxmlformats.org/drawingml/2006/main" xmlns:p="http://schemas.openxmlformats.org/presentationml/2006/main" xmlns:r="http://schemas.openxmlformats.org/officeDocument/2006/relationships">
   <p:cSld>
@@ -4343,6 +4413,146 @@
           <a:p>
             <a:r>
               <a:t>화면에서 직접 눌러 확인하면 사용자가 겪는 흐름을 볼 수 있습니다. 다만 한 번 잘 됐다는 기억만으로 변경을 판단하기는 어렵습니다. 승인 단계에도 승인과 거절, 무응답, 권한 없는 요청처럼 여러 경우가 있으니까요. 첫 카드처럼 한 번의 실행은 그중 한 경우를 보여 줍니다. 둘째 카드처럼 기능을 바꾸면 기존 경우도 다시 확인해야 하죠. 그때 무엇을 넣었고 어떤 결과가 맞는지 남기지 않았다면, 셋째 카드처럼 확인하는 사람마다 판단이 달라질 수 있습니다. 손으로 시험해도 입력과 기대 결과를 기록할 수 있습니다. 새로운 문제를 탐색하거나 화면을 이해하기 쉬운지 보는 데도 사람의 확인이 필요해요. 여기서는 반복할 조건을 명확히 남기고 자동으로 다시 확인할 수 있게 만드는 데 초점을 두겠습니다. 사람의 기억에만 기대던 확인을 다음 변경에도 쓸 수 있는 기준으로 바꾸는 겁니다.</a:t>
+            </a:r>
+          </a:p>
+        </p:txBody>
+      </p:sp>
+      <p:sp>
+        <p:nvSpPr>
+          <p:cNvPr id="4" name="Slide Number Placeholder 3"/>
+          <p:cNvSpPr>
+            <a:spLocks noGrp="1"/>
+          </p:cNvSpPr>
+          <p:nvPr>
+            <p:ph type="sldNum" idx="5" sz="quarter"/>
+          </p:nvPr>
+        </p:nvSpPr>
+        <p:spPr/>
+      </p:sp>
+    </p:spTree>
+  </p:cSld>
+  <p:clrMapOvr>
+    <a:masterClrMapping/>
+  </p:clrMapOvr>
+</p:notes>
+</file>
+
+<file path=ppt/notesSlides/notesSlide60.xml><?xml version="1.0" encoding="utf-8"?>
+<p:notes xmlns:a="http://schemas.openxmlformats.org/drawingml/2006/main" xmlns:p="http://schemas.openxmlformats.org/presentationml/2006/main" xmlns:r="http://schemas.openxmlformats.org/officeDocument/2006/relationships">
+  <p:cSld>
+    <p:spTree>
+      <p:nvGrpSpPr>
+        <p:cNvPr id="1" name=""/>
+        <p:cNvGrpSpPr/>
+        <p:nvPr/>
+      </p:nvGrpSpPr>
+      <p:grpSpPr>
+        <a:xfrm>
+          <a:off x="0" y="0"/>
+          <a:ext cx="0" cy="0"/>
+          <a:chOff x="0" y="0"/>
+          <a:chExt cx="0" cy="0"/>
+        </a:xfrm>
+      </p:grpSpPr>
+      <p:sp>
+        <p:nvSpPr>
+          <p:cNvPr id="2" name="Slide Image Placeholder 1"/>
+          <p:cNvSpPr>
+            <a:spLocks noGrp="1"/>
+          </p:cNvSpPr>
+          <p:nvPr>
+            <p:ph type="sldImg" idx="2"/>
+          </p:nvPr>
+        </p:nvSpPr>
+        <p:spPr/>
+      </p:sp>
+      <p:sp>
+        <p:nvSpPr>
+          <p:cNvPr id="3" name="Notes Placeholder 2"/>
+          <p:cNvSpPr>
+            <a:spLocks noGrp="1"/>
+          </p:cNvSpPr>
+          <p:nvPr>
+            <p:ph type="body" idx="3" sz="quarter"/>
+          </p:nvPr>
+        </p:nvSpPr>
+        <p:spPr/>
+        <p:txBody>
+          <a:bodyPr/>
+          <a:lstStyle/>
+          <a:p>
+            <a:r>
+              <a:t>33~34장 통합 발화는 33장 발표자 노트를 따른다.</a:t>
+            </a:r>
+          </a:p>
+        </p:txBody>
+      </p:sp>
+      <p:sp>
+        <p:nvSpPr>
+          <p:cNvPr id="4" name="Slide Number Placeholder 3"/>
+          <p:cNvSpPr>
+            <a:spLocks noGrp="1"/>
+          </p:cNvSpPr>
+          <p:nvPr>
+            <p:ph type="sldNum" idx="5" sz="quarter"/>
+          </p:nvPr>
+        </p:nvSpPr>
+        <p:spPr/>
+      </p:sp>
+    </p:spTree>
+  </p:cSld>
+  <p:clrMapOvr>
+    <a:masterClrMapping/>
+  </p:clrMapOvr>
+</p:notes>
+</file>
+
+<file path=ppt/notesSlides/notesSlide61.xml><?xml version="1.0" encoding="utf-8"?>
+<p:notes xmlns:a="http://schemas.openxmlformats.org/drawingml/2006/main" xmlns:p="http://schemas.openxmlformats.org/presentationml/2006/main" xmlns:r="http://schemas.openxmlformats.org/officeDocument/2006/relationships">
+  <p:cSld>
+    <p:spTree>
+      <p:nvGrpSpPr>
+        <p:cNvPr id="1" name=""/>
+        <p:cNvGrpSpPr/>
+        <p:nvPr/>
+      </p:nvGrpSpPr>
+      <p:grpSpPr>
+        <a:xfrm>
+          <a:off x="0" y="0"/>
+          <a:ext cx="0" cy="0"/>
+          <a:chOff x="0" y="0"/>
+          <a:chExt cx="0" cy="0"/>
+        </a:xfrm>
+      </p:grpSpPr>
+      <p:sp>
+        <p:nvSpPr>
+          <p:cNvPr id="2" name="Slide Image Placeholder 1"/>
+          <p:cNvSpPr>
+            <a:spLocks noGrp="1"/>
+          </p:cNvSpPr>
+          <p:nvPr>
+            <p:ph type="sldImg" idx="2"/>
+          </p:nvPr>
+        </p:nvSpPr>
+        <p:spPr/>
+      </p:sp>
+      <p:sp>
+        <p:nvSpPr>
+          <p:cNvPr id="3" name="Notes Placeholder 2"/>
+          <p:cNvSpPr>
+            <a:spLocks noGrp="1"/>
+          </p:cNvSpPr>
+          <p:nvPr>
+            <p:ph type="body" idx="3" sz="quarter"/>
+          </p:nvPr>
+        </p:nvSpPr>
+        <p:spPr/>
+        <p:txBody>
+          <a:bodyPr/>
+          <a:lstStyle/>
+          <a:p>
+            <a:r>
+              <a:t>35~36장 통합 발화는 35장 발표자 노트를 따른다.</a:t>
             </a:r>
           </a:p>
         </p:txBody>
@@ -4412,7 +4622,7 @@
           <a:lstStyle/>
           <a:p>
             <a:r>
-              <a:t>이 문제를 다루는 방식이 BDD, 행동 주도 개발입니다. 업무를 아는 사람과 개발하고 검증하는 사람이 구체적인 사례를 놓고, 어떤 행동이 필요한지 함께 정하는 방식이에요. 먼저 기대를 맞추고, 사례를 시나리오로 적고, 실행 가능한 검증에 연결합니다. 예를 들어 거절한다는 말만 같아도, 한 사람은 승인 화면만 닫힌다고 생각하고 다른 사람은 처리 건까지 종료된다고 생각할 수 있죠. 거절하면 명령은 몇 건이고 처리 상태는 무엇인지 구체적으로 물으면 이 차이가 드러납니다. 코드를 만든 뒤에야 서로 다른 기대를 발견하는 일을 줄이는 거예요. 화면의 행동은 시스템 밖에서 확인할 수 있는 결과를 뜻합니다. 내부에서 어떤 함수를 썼느냐보다, 담당자가 거절했을 때 설비 명령이 생기지 않고 사유가 남는지를 보는 겁니다. 시나리오는 이런 상황과 기대를 구체적인 예로 적은 글이에요. 이번 시간에는 이미 정리한 명세를 바탕으로 시나리오를 만들고 검증에 연결하는 부분을 살펴보겠습니다. 실제 개발에서는 시나리오를 논의하다가 빠진 요구를 찾아 명세를 보완할 수도 있어요. [출처·낭독 제외] https://cucumber.io/docs/bdd/</a:t>
+              <a:t>이 문제를 다루는 방식이 BDD, 행동 주도 개발입니다. 업무를 아는 사람과 개발하고 검증하는 사람이 구체적인 사례를 놓고, 어떤 행동이 필요한지 함께 정하는 방식이에요. 먼저 기대를 맞추고, 사례를 시나리오로 적고, 실행 가능한 검증에 연결합니다. 예를 들어 거절한다는 말만 같아도, 한 사람은 승인 화면만 닫힌다고 생각하고 다른 사람은 처리 건까지 종료된다고 생각할 수 있죠. 거절하면 명령은 몇 건이고 처리 상태는 무엇인지 구체적으로 물으면 이 차이가 드러납니다. 코드를 만든 뒤에야 서로 다른 기대를 발견하는 일을 줄이는 거예요. 화면의 행동은 시스템 밖에서 확인할 수 있는 결과를 뜻합니다. 내부에서 어떤 함수를 썼느냐보다, 담당자가 거절했을 때 설비 명령이 생기지 않고 사유가 남는지를 보는 겁니다. 시나리오는 이런 상황과 기대를 구체적인 예로 적은 글이에요. 이번 시간에는 이미 정리한 명세를 바탕으로 시나리오를 만들고 검증에 연결하는 부분을 살펴보겠습니다. 실제 개발에서는 시나리오를 논의하다가 빠진 요구를 찾아 명세를 보완할 수도 있어요.</a:t>
             </a:r>
           </a:p>
         </p:txBody>
@@ -4552,7 +4762,7 @@
           <a:lstStyle/>
           <a:p>
             <a:r>
-              <a:t>앞의 거절을 구조가 보이는 글로 적은 예입니다. 맨 위는 기능 이름, 그 아래는 시나리오 이름이에요. 이어서 전제와 행동, 기대 결과를 적습니다. 이 구조로 시나리오를 쓰는 언어를 Gherkin이라고 합니다. Then 아래의 And는 앞부분에 같은 종류의 조건을 이어 붙이는 말입니다. 여기서는 설비 명령이 없다는 조건에 업무 처리도 없고 거절로 닫힌다는 결과를 더했어요. 하지 않아야 할 일도 기대 결과로 적는다는 점을 보세요. Gherkin은 BDD에서 널리 쓰이는 표현 방법입니다. 이 서식을 썼다고 바로 자동 시험이 완성되는 것은 아닙니다. 실행과 대조를 맡을 코드에 연결해야 해요. 여기서는 문장의 구조를 읽고, 이어지는 HYD의 파이썬 시험에서 같은 전제와 행동, 결과가 어떻게 연결되는지 보겠습니다. [출처·낭독 제외] https://cucumber.io/docs/gherkin/reference/</a:t>
+              <a:t>앞의 거절을 구조가 보이는 글로 적은 예입니다. 맨 위는 기능 이름, 그 아래는 시나리오 이름이에요. 이어서 전제와 행동, 기대 결과를 적습니다. 이 구조로 시나리오를 쓰는 언어를 Gherkin이라고 합니다. Then 아래의 And는 앞부분에 같은 종류의 조건을 이어 붙이는 말입니다. 여기서는 설비 명령이 없다는 조건에 업무 처리도 없고 거절로 닫힌다는 결과를 더했어요. 하지 않아야 할 일도 기대 결과로 적는다는 점을 보세요. Gherkin은 BDD에서 널리 쓰이는 표현 방법입니다. 이 서식을 썼다고 바로 자동 시험이 완성되는 것은 아닙니다. 실행과 대조를 맡을 코드에 연결해야 해요. 여기서는 문장의 구조를 읽고, 이어지는 HYD의 파이썬 시험에서 같은 전제와 행동, 결과가 어떻게 연결되는지 보겠습니다.</a:t>
             </a:r>
           </a:p>
         </p:txBody>

</xml_diff>